<commit_message>
PDF da apresentação; troca travessões por hífen; remove o .pbix, o anexo e ferramentas internas do repositório
Co-Authored-By: Claude Opus 5.5 <noreply@anthropic.com>
</commit_message>
<xml_diff>
--- a/omie-case-contadores/output/Apresentacao_Omie_Canal_Contadores.pptx
+++ b/omie-case-contadores/output/Apresentacao_Omie_Canal_Contadores.pptx
@@ -112,32 +112,32 @@
   <p:extLst>
     <p:ext uri="{521415D9-36F7-43E2-AB2F-B90AF26B5E84}">
       <p14:sectionLst xmlns:p14="http://schemas.microsoft.com/office/powerpoint/2010/main">
-        <p14:section name="Oportunidade" id="{c3ff6eae-8400-4b9f-c0aa-a32a4f83078e}">
+        <p14:section name="Oportunidade" id="{d86082dd-3739-dd64-b8af-163e104c50a3}">
           <p14:sldIdLst>
             <p14:sldId id="256"/>
           </p14:sldIdLst>
         </p14:section>
-        <p14:section name="Onde está o dinheiro" id="{380f6dd5-c4be-af56-fb9b-30b343e77d1e}">
+        <p14:section name="Onde está o dinheiro" id="{cd0e1df0-e4ed-562f-99a7-7431cfb20688}">
           <p14:sldIdLst>
             <p14:sldId id="257"/>
           </p14:sldIdLst>
         </p14:section>
-        <p14:section name="Drivers de conversão" id="{2add3671-d4ea-f524-de33-ef868e0422a3}">
+        <p14:section name="Drivers de conversão" id="{565b8664-8431-867b-09f6-776dade9c959}">
           <p14:sldIdLst>
             <p14:sldId id="258"/>
           </p14:sldIdLst>
         </p14:section>
-        <p14:section name="Capacity e EC adicional" id="{37d18f37-881d-6483-b6d5-edc6fa1d69e3}">
+        <p14:section name="Capacity e EC adicional" id="{d88649a2-d305-e69c-3bbf-6f2152dfdf50}">
           <p14:sldIdLst>
             <p14:sldId id="259"/>
           </p14:sldIdLst>
         </p14:section>
-        <p14:section name="Ações imediatas" id="{90f4df8e-3580-907d-fefb-ae7bfde1d057}">
+        <p14:section name="Ações imediatas" id="{84b20fa3-0698-1c75-3570-3ab448ffda33}">
           <p14:sldIdLst>
             <p14:sldId id="260"/>
           </p14:sldIdLst>
         </p14:section>
-        <p14:section name="KPI de 90 dias" id="{5b92eaf8-a255-ff0b-be2f-aa60e2f75903}">
+        <p14:section name="KPI de 90 dias" id="{683a4096-abeb-6a0f-29b4-d527e9b41669}">
           <p14:sldIdLst>
             <p14:sldId id="261"/>
           </p14:sldIdLst>
@@ -3403,7 +3403,7 @@
                   <a:schemeClr val="bg1"/>
                 </a:solidFill>
               </a:rPr>
-              <a:t>51% do canal ainda está fora da Omie —</a:t>
+              <a:t>51% do canal ainda está fora da Omie -</a:t>
             </a:r>
             <a:endParaRPr lang="en-US" sz="2800" dirty="0"/>
           </a:p>
@@ -3973,7 +3973,7 @@
                   <a:schemeClr val="tx1"/>
                 </a:solidFill>
               </a:rPr>
-              <a:t>O que sobra: Sudeste e escritórios pequenos —</a:t>
+              <a:t>O que sobra: Sudeste e escritórios pequenos -</a:t>
             </a:r>
             <a:endParaRPr lang="en-US" sz="2800" dirty="0"/>
           </a:p>
@@ -4535,7 +4535,7 @@
                   <a:schemeClr val="tx1"/>
                 </a:solidFill>
               </a:rPr>
-              <a:t>Converte mais quem é maior, estruturado e usa ERP —</a:t>
+              <a:t>Converte mais quem é maior, estruturado e usa ERP -</a:t>
             </a:r>
             <a:endParaRPr lang="en-US" sz="2800" dirty="0"/>
           </a:p>
@@ -5565,7 +5565,7 @@
                   <a:schemeClr val="tx1"/>
                 </a:solidFill>
               </a:rPr>
-              <a:t>R$ 19,5 mil/mês de gap em 9 franquias: maturidade —</a:t>
+              <a:t>R$ 19,5 mil/mês de gap em 9 franquias: maturidade -</a:t>
             </a:r>
             <a:endParaRPr lang="en-US" sz="2800" dirty="0"/>
           </a:p>

</xml_diff>

<commit_message>
Revisão final: gap lido pelo nº de ECs (meses_operando contradiz data_inicio), rede 6,3 endereçáveis por EC, carga dos ECs da BA, KPI do tier Alta e textos corrigidos
Co-Authored-By: Claude Opus 5.5 <noreply@anthropic.com>
</commit_message>
<xml_diff>
--- a/omie-case-contadores/output/Apresentacao_Omie_Canal_Contadores.pptx
+++ b/omie-case-contadores/output/Apresentacao_Omie_Canal_Contadores.pptx
@@ -112,32 +112,32 @@
   <p:extLst>
     <p:ext uri="{521415D9-36F7-43E2-AB2F-B90AF26B5E84}">
       <p14:sectionLst xmlns:p14="http://schemas.microsoft.com/office/powerpoint/2010/main">
-        <p14:section name="Oportunidade" id="{d86082dd-3739-dd64-b8af-163e104c50a3}">
+        <p14:section name="Oportunidade" id="{24cabcd7-eb7e-629d-f398-9107d6eaa042}">
           <p14:sldIdLst>
             <p14:sldId id="256"/>
           </p14:sldIdLst>
         </p14:section>
-        <p14:section name="Onde está o dinheiro" id="{cd0e1df0-e4ed-562f-99a7-7431cfb20688}">
+        <p14:section name="Onde está o dinheiro" id="{3b428058-c909-6d53-2574-b9aa48dbf3c8}">
           <p14:sldIdLst>
             <p14:sldId id="257"/>
           </p14:sldIdLst>
         </p14:section>
-        <p14:section name="Drivers de conversão" id="{565b8664-8431-867b-09f6-776dade9c959}">
+        <p14:section name="Drivers de conversão" id="{510c733f-0451-12b9-f4b6-6a1af83f65fa}">
           <p14:sldIdLst>
             <p14:sldId id="258"/>
           </p14:sldIdLst>
         </p14:section>
-        <p14:section name="Capacity e EC adicional" id="{d88649a2-d305-e69c-3bbf-6f2152dfdf50}">
+        <p14:section name="Capacity e EC adicional" id="{b8ddeec5-66aa-a5d7-efa1-5c1dee2d5eb4}">
           <p14:sldIdLst>
             <p14:sldId id="259"/>
           </p14:sldIdLst>
         </p14:section>
-        <p14:section name="Ações imediatas" id="{84b20fa3-0698-1c75-3570-3ab448ffda33}">
+        <p14:section name="Ações imediatas" id="{8bdecf49-aefa-20d0-6fd4-02a0505f9fbf}">
           <p14:sldIdLst>
             <p14:sldId id="260"/>
           </p14:sldIdLst>
         </p14:section>
-        <p14:section name="KPI de 90 dias" id="{683a4096-abeb-6a0f-29b4-d527e9b41669}">
+        <p14:section name="KPI de 90 dias" id="{5ad42149-0588-73e3-5cff-e722c560d785}">
           <p14:sldIdLst>
             <p14:sldId id="261"/>
           </p14:sldIdLst>
@@ -1118,7 +1118,7 @@
                 </a:solidFill>
                 <a:latin typeface="+mn-lt"/>
               </a:rPr>
-              <a:t>Atingimento da meta · franquia e meses de operação</a:t>
+              <a:t>Atingimento da meta · franquia e nº de ECs</a:t>
             </a:r>
           </a:p>
         </c:rich>
@@ -1186,49 +1186,49 @@
                 <c:ptCount val="15"/>
                 <c:lvl>
                   <c:pt idx="0">
-                    <c:v>PA · 3m</c:v>
+                    <c:v>PA · 1 EC</c:v>
                   </c:pt>
                   <c:pt idx="1">
-                    <c:v>AM · 3m</c:v>
+                    <c:v>AM · 1 EC</c:v>
                   </c:pt>
                   <c:pt idx="2">
-                    <c:v>BA · 6m</c:v>
+                    <c:v>BA · 2 EC</c:v>
                   </c:pt>
                   <c:pt idx="3">
-                    <c:v>PE · 5m</c:v>
+                    <c:v>PE · 2 EC</c:v>
                   </c:pt>
                   <c:pt idx="4">
-                    <c:v>CE · 4m</c:v>
+                    <c:v>CE · 1 EC</c:v>
                   </c:pt>
                   <c:pt idx="5">
-                    <c:v>RJ · 14m</c:v>
+                    <c:v>RJ · 5 EC</c:v>
                   </c:pt>
                   <c:pt idx="6">
-                    <c:v>GO · 7m</c:v>
+                    <c:v>GO · 2 EC</c:v>
                   </c:pt>
                   <c:pt idx="7">
-                    <c:v>DF · 9m</c:v>
+                    <c:v>DF · 3 EC</c:v>
                   </c:pt>
                   <c:pt idx="8">
-                    <c:v>RS · 11m</c:v>
+                    <c:v>RS · 4 EC</c:v>
                   </c:pt>
                   <c:pt idx="9">
-                    <c:v>ES · 5m</c:v>
+                    <c:v>ES · 2 EC</c:v>
                   </c:pt>
                   <c:pt idx="10">
-                    <c:v>SP Interior · 12m</c:v>
+                    <c:v>SP Interior · 4 EC</c:v>
                   </c:pt>
                   <c:pt idx="11">
-                    <c:v>PR · 16m</c:v>
+                    <c:v>PR · 5 EC</c:v>
                   </c:pt>
                   <c:pt idx="12">
-                    <c:v>MG · 10m</c:v>
+                    <c:v>MG · 3 EC</c:v>
                   </c:pt>
                   <c:pt idx="13">
-                    <c:v>SP Capital · 18m</c:v>
+                    <c:v>SP Capital · 6 EC</c:v>
                   </c:pt>
                   <c:pt idx="14">
-                    <c:v>SC · 8m</c:v>
+                    <c:v>SC · 3 EC</c:v>
                   </c:pt>
                 </c:lvl>
               </c:multiLvlStrCache>
@@ -1342,49 +1342,49 @@
                 <c:ptCount val="15"/>
                 <c:lvl>
                   <c:pt idx="0">
-                    <c:v>PA · 3m</c:v>
+                    <c:v>PA · 1 EC</c:v>
                   </c:pt>
                   <c:pt idx="1">
-                    <c:v>AM · 3m</c:v>
+                    <c:v>AM · 1 EC</c:v>
                   </c:pt>
                   <c:pt idx="2">
-                    <c:v>BA · 6m</c:v>
+                    <c:v>BA · 2 EC</c:v>
                   </c:pt>
                   <c:pt idx="3">
-                    <c:v>PE · 5m</c:v>
+                    <c:v>PE · 2 EC</c:v>
                   </c:pt>
                   <c:pt idx="4">
-                    <c:v>CE · 4m</c:v>
+                    <c:v>CE · 1 EC</c:v>
                   </c:pt>
                   <c:pt idx="5">
-                    <c:v>RJ · 14m</c:v>
+                    <c:v>RJ · 5 EC</c:v>
                   </c:pt>
                   <c:pt idx="6">
-                    <c:v>GO · 7m</c:v>
+                    <c:v>GO · 2 EC</c:v>
                   </c:pt>
                   <c:pt idx="7">
-                    <c:v>DF · 9m</c:v>
+                    <c:v>DF · 3 EC</c:v>
                   </c:pt>
                   <c:pt idx="8">
-                    <c:v>RS · 11m</c:v>
+                    <c:v>RS · 4 EC</c:v>
                   </c:pt>
                   <c:pt idx="9">
-                    <c:v>ES · 5m</c:v>
+                    <c:v>ES · 2 EC</c:v>
                   </c:pt>
                   <c:pt idx="10">
-                    <c:v>SP Interior · 12m</c:v>
+                    <c:v>SP Interior · 4 EC</c:v>
                   </c:pt>
                   <c:pt idx="11">
-                    <c:v>PR · 16m</c:v>
+                    <c:v>PR · 5 EC</c:v>
                   </c:pt>
                   <c:pt idx="12">
-                    <c:v>MG · 10m</c:v>
+                    <c:v>MG · 3 EC</c:v>
                   </c:pt>
                   <c:pt idx="13">
-                    <c:v>SP Capital · 18m</c:v>
+                    <c:v>SP Capital · 6 EC</c:v>
                   </c:pt>
                   <c:pt idx="14">
-                    <c:v>SC · 8m</c:v>
+                    <c:v>SC · 3 EC</c:v>
                   </c:pt>
                 </c:lvl>
               </c:multiLvlStrCache>
@@ -2187,7 +2187,7 @@
             <a:r>
               <a:rPr lang="en-US" dirty="0"/>
               <a:t>Propensão à conversão. Fiz uma análise descritiva: para cada característica do contador, calculei a taxa de conversão de cada categoria. A característica que mais separa quem converte de quem não converte é a que tem maior diferença entre a melhor e a pior categoria. Em ordem: porte, nº de funcionários, nº de clientes da carteira, erp atual e anos de mercado. A propensão de cada contador é a média das taxas de conversão do perfil dele nessas cinco características: sem modelo e sem pesos. O score ordena bem: a faixa Alta, Média e Baixa convertem 91% · 29% · 3%; o top 30% converte 2,3 vezes a média e capta 69% dos convertidos.
-O ponto mais importante está no gráfico: pela base, Médio e Grande convertem quase sempre e o Autônomo quase nunca. Mas no pipeline real o fechamento é parecido em todos os portes. E o top 30% do score fecha 60% no pipeline real, contra 65% nas demais faixas. Ou seja, a coluna de conversão mede potencial, não fechamento.
+O ponto mais importante está no gráfico: pela base, Médio e Grande convertem quase sempre e o Autônomo quase nunca. Mas no pipeline real o fechamento não segue esse padrão: o Autônomo fecha 67% e o Médio, 46%. E o top 30% do score fecha 60% no pipeline real, contra 65% nas demais faixas. Ou seja, a coluna de conversão mede potencial, não fechamento.
 Por isso trato o impacto como hipótese: +25% de nMRR no cenário base, cerca de R$ 31 mil por mês nas franquias abaixo da meta. Para saber se funciona, a métrica é simples: num piloto de 90 dias, o grupo que prioriza o topo do score fecha mais do que o grupo de controle?</a:t>
             </a:r>
             <a:endParaRPr lang="en-US" dirty="0"/>
@@ -2276,9 +2276,9 @@
           <a:p>
             <a:r>
               <a:rPr lang="en-US" dirty="0"/>
-              <a:t>Capacity. São 9 franquias abaixo da meta, com gap de R$ 19,5 mil por mês. A primeira hipótese seria execução, mas os dados não sustentam: as taxas do funil são praticamente iguais entre franquias e a correlação da etapa proposta → fechamento com o atingimento é de só 0,15. O que explica o gap é maturidade: correlação de 0,65 entre meses de operação e atingimento.
-A rede como um todo bate a meta; os R$ 19,5 mil são o gap das 9 franquias abaixo dela. Por região: Norte, Nordeste e Centro-Oeste estão abaixo da meta como região (74%, 82% e 89%); Sudeste e Sul batem a meta (107% e 108%) e o gap vem só do RJ, com 14 meses e o maior gap da rede, e do RS. O CE, por exemplo, tem a maior meta por EC da rede e realiza acima da média por EC: parte do gap é meta, não execução.
-Sobre o EC adicional: usei só dados da base. O EC vai para onde há mais fechamentos potenciais por EC, que é a demanda do território por EC vezes a conversão do funil da própria franquia. A BA lidera: 12,5 endereçáveis por EC, contra 6,6 na média da rede, e conversão de 4,5%, contra 4,0% da rede (2ª em demanda e 3ª em conversão). O realizado por EC ainda baixo é coerente com 6 meses de operação. A 2ª opção é MG, que já está acima da meta. Os 27 endereçáveis de MT, MA, RO e MS não têm franquia nem histórico de execução, então não dá para avaliá-los com dado.</a:t>
+              <a:t>Capacity. São 9 franquias abaixo da meta, com gap de R$ 19,5 mil por mês. A primeira hipótese seria execução, mas os dados não sustentam: as taxas do funil são praticamente iguais entre franquias e a correlação da etapa proposta → fechamento com o atingimento é de só 0,15. O gap está nas franquias pequenas: das 7 com 1 a 2 ECs, 6 estão abaixo da meta, e a correlação entre nº de ECs e atingimento é de 0,64. Não chamo isso de maturidade: a coluna meses_operando diz o mesmo, mas contradiz a data_inicio da própria tabela, e pela data de início a correlação é negativa (-0,37). É mais um ponto de governança.
+A rede como um todo bate a meta; os R$ 19,5 mil são o gap das 9 franquias abaixo dela. Por região: Norte, Nordeste e Centro-Oeste estão abaixo da meta como região (74%, 82% e 89%); Sudeste e Sul batem a meta (107% e 108%) e o gap vem só do RJ, que tem o maior gap da rede, e do RS. O CE, por exemplo, tem a maior meta por EC da rede e realiza acima da média por EC: parte do gap é meta, não execução.
+Sobre o EC adicional: usei só dados da base. O EC vai para onde há mais fechamentos potenciais por EC, que é a demanda do território por EC vezes a conversão do funil da própria franquia. A BA lidera: 12,5 endereçáveis por EC, contra 6,3 da rede, e conversão de 4,5%, contra 4,0% da rede (2ª em demanda e 3ª em conversão). E os ECs dela já são os mais carregados da rede: 18,7 leads trabalhados por mês, contra 16,5. A margem é pequena: 0,56 contra 0,50 fechamentos potenciais por EC da MG, que converte parecido (4,7%) e já está acima da meta. A diferença vem da demanda por EC. Os 27 endereçáveis de MT, MA, RO e MS não têm franquia nem histórico de execução, então não dá para avaliá-los com dado.</a:t>
             </a:r>
             <a:endParaRPr lang="en-US" dirty="0"/>
           </a:p>
@@ -2368,9 +2368,9 @@
               <a:rPr lang="en-US" dirty="0"/>
               <a:t>As três ações para o campo, em ordem de prioridade.
 Primeira: fechar o que já está quente. São 15 contadores com lead ativo em reunião ou proposta, o único sinal real de compra que temos, independente de qualquer perfil. Junto com isso, limpar o pipeline: 56% dos leads abertos estão parados há mais de 90 dias, o dobro do ciclo médio de um ganho. Isso libera tempo de EC e torna a cobertura confiável.
-Segunda: o piloto do tier Alta, a lista priorizada da pergunta C: carteira acima de 24 clientes e lead em andamento. São 21 contadores; 8 já estão em negociação, então o piloto ataca os outros 13. Metade dos ECs ataca essa lista, a outra metade é o grupo de controle. Em 90 dias eu sei se o perfil gera receita de verdade.
+Segunda: o piloto do tier Alta, a lista priorizada da pergunta C: carteira acima de 24 clientes com lead em andamento, ou de 15 a 24 com lead em reunião ou proposta. São 21 contadores; 8 já estão em negociação, então o piloto ataca os outros 13. Metade dos ECs ataca essa lista, a outra metade é o grupo de controle. Em 90 dias eu sei se o perfil gera receita de verdade.
 Terceira: proposta → fechamento é a etapa de menor conversão, 19%. Cinco pontos percentuais a mais nela valem 26% de nMRR.
-Embaixo estão as três decisões de gestão que sustentam isso: meta ajustada à maturidade, plano para o RJ e o EC adicional em BA.</a:t>
+Embaixo estão as três decisões de gestão que sustentam isso: meta revista nas franquias pequenas, plano para o RJ e o EC adicional em BA.</a:t>
             </a:r>
             <a:endParaRPr lang="en-US" dirty="0"/>
           </a:p>
@@ -5565,7 +5565,7 @@
                   <a:schemeClr val="tx1"/>
                 </a:solidFill>
               </a:rPr>
-              <a:t>R$ 19,5 mil/mês de gap em 9 franquias: maturidade -</a:t>
+              <a:t>R$ 19,5 mil/mês de gap, concentrado nas franquias pequenas -</a:t>
             </a:r>
             <a:endParaRPr lang="en-US" sz="2800" dirty="0"/>
           </a:p>
@@ -5661,7 +5661,7 @@
                 <a:ea typeface="+mj-lt" pitchFamily="34" charset="-122"/>
                 <a:cs typeface="+mj-lt" pitchFamily="34" charset="-120"/>
               </a:rPr>
-              <a:t>0,65</a:t>
+              <a:t>0,64</a:t>
             </a:r>
             <a:endParaRPr lang="en-US" sz="2600" dirty="0"/>
           </a:p>
@@ -5697,7 +5697,7 @@
                   <a:schemeClr val="tx1"/>
                 </a:solidFill>
               </a:rPr>
-              <a:t>Correlação: Maturidade</a:t>
+              <a:t>Correlação: Tamanho</a:t>
             </a:r>
             <a:endParaRPr lang="en-US" sz="1200" dirty="0"/>
           </a:p>
@@ -5711,7 +5711,7 @@
                   <a:schemeClr val="tx1"/>
                 </a:solidFill>
               </a:rPr>
-              <a:t>meses de operação × atingimento</a:t>
+              <a:t>nº de ECs × atingimento</a:t>
             </a:r>
             <a:endParaRPr lang="en-US" sz="1200" dirty="0"/>
           </a:p>
@@ -5937,7 +5937,7 @@
                   <a:schemeClr val="tx1"/>
                 </a:solidFill>
               </a:rPr>
-              <a:t>região a 82% da meta; BA, PE, CE abaixo, com 4 a 6 meses</a:t>
+              <a:t>região a 82% da meta; BA, PE, CE abaixo, com 1 a 2 ECs</a:t>
             </a:r>
             <a:endParaRPr lang="en-US" sz="1300" dirty="0"/>
           </a:p>
@@ -6237,7 +6237,7 @@
                   <a:schemeClr val="bg1"/>
                 </a:solidFill>
               </a:rPr>
-              <a:t>Mais fechamentos potenciais por EC: 12,5 endereçáveis por EC (rede: 6,6) e conversão de 4,5% (rede: 4,0%), com gap de R$ 3 mil. 2ª opção: MG.</a:t>
+              <a:t>Mais fechamentos potenciais por EC: 12,5 endereçáveis por EC (rede: 6,3), conversão de 4,5% (rede: 4,0%) e os ECs mais carregados (18,7 leads/mês; rede: 16,5). 2ª opção, por pouco: MG.</a:t>
             </a:r>
             <a:endParaRPr lang="en-US" sz="1300" dirty="0"/>
           </a:p>
@@ -7137,7 +7137,7 @@
                   <a:srgbClr val="FFFFFF"/>
                 </a:solidFill>
               </a:rPr>
-              <a:t>Metas ajustadas à maturidade</a:t>
+              <a:t>Metas das franquias pequenas</a:t>
             </a:r>
             <a:endParaRPr lang="en-US" sz="1200" dirty="0"/>
           </a:p>
@@ -8840,7 +8840,7 @@
                           <a:ea typeface="Calibri" pitchFamily="34" charset="-122"/>
                           <a:cs typeface="Calibri" pitchFamily="34" charset="-120"/>
                         </a:rPr>
-                        <a:t>Contadores do tier Alta trabalhados</a:t>
+                        <a:t>Tier Alta com lead em Reunião/Proposta</a:t>
                       </a:r>
                       <a:endParaRPr lang="en-US" sz="1300" dirty="0">
                         <a:latin typeface="Calibri" charset="0"/>
@@ -8905,7 +8905,7 @@
                           <a:ea typeface="Calibri" pitchFamily="34" charset="-122"/>
                           <a:cs typeface="Calibri" pitchFamily="34" charset="-120"/>
                         </a:rPr>
-                        <a:t>0 de 21</a:t>
+                        <a:t>8 de 21</a:t>
                       </a:r>
                       <a:endParaRPr lang="en-US" sz="1300" dirty="0">
                         <a:latin typeface="Calibri" charset="0"/>
@@ -9208,7 +9208,7 @@
                   <a:srgbClr val="4E6B74"/>
                 </a:solidFill>
               </a:rPr>
-              <a:t>Hoje: franquias, stg_lead e Desafio 3 · Painel Omie (Power BI) · sinais de sucesso a validar com a liderança</a:t>
+              <a:t>Hoje: franquias, leads_pipeline e Desafio 3 · Painel Omie (Power BI) · sinais de sucesso a validar com a liderança</a:t>
             </a:r>
             <a:endParaRPr lang="en-US" sz="1000" dirty="0"/>
           </a:p>

</xml_diff>

<commit_message>
Previsibilidade de receita: pipeline ponderado e run-rate do CRM (aba Previsao_Receita, página 4 do painel e slide 3)
Co-Authored-By: Claude Opus 5.5 <noreply@anthropic.com>
</commit_message>
<xml_diff>
--- a/omie-case-contadores/output/Apresentacao_Omie_Canal_Contadores.pptx
+++ b/omie-case-contadores/output/Apresentacao_Omie_Canal_Contadores.pptx
@@ -112,32 +112,32 @@
   <p:extLst>
     <p:ext uri="{521415D9-36F7-43E2-AB2F-B90AF26B5E84}">
       <p14:sectionLst xmlns:p14="http://schemas.microsoft.com/office/powerpoint/2010/main">
-        <p14:section name="Oportunidade" id="{24cabcd7-eb7e-629d-f398-9107d6eaa042}">
+        <p14:section name="Oportunidade" id="{70f5e4c4-1d61-283c-0832-4b56694c0367}">
           <p14:sldIdLst>
             <p14:sldId id="256"/>
           </p14:sldIdLst>
         </p14:section>
-        <p14:section name="Onde está o dinheiro" id="{3b428058-c909-6d53-2574-b9aa48dbf3c8}">
+        <p14:section name="Onde está o dinheiro" id="{4de689a4-dc15-9010-02ec-9c30ed352db0}">
           <p14:sldIdLst>
             <p14:sldId id="257"/>
           </p14:sldIdLst>
         </p14:section>
-        <p14:section name="Drivers de conversão" id="{510c733f-0451-12b9-f4b6-6a1af83f65fa}">
+        <p14:section name="Drivers de conversão" id="{8e4fd4d7-a7ee-37a8-f858-0f1fbc2c548b}">
           <p14:sldIdLst>
             <p14:sldId id="258"/>
           </p14:sldIdLst>
         </p14:section>
-        <p14:section name="Capacity e EC adicional" id="{b8ddeec5-66aa-a5d7-efa1-5c1dee2d5eb4}">
+        <p14:section name="Capacity e EC adicional" id="{8e8cb24d-c963-327d-31ef-379b01c42264}">
           <p14:sldIdLst>
             <p14:sldId id="259"/>
           </p14:sldIdLst>
         </p14:section>
-        <p14:section name="Ações imediatas" id="{8bdecf49-aefa-20d0-6fd4-02a0505f9fbf}">
+        <p14:section name="Ações imediatas" id="{c23e49cc-3d7f-fed6-426f-7c422a7b9335}">
           <p14:sldIdLst>
             <p14:sldId id="260"/>
           </p14:sldIdLst>
         </p14:section>
-        <p14:section name="KPI de 90 dias" id="{5ad42149-0588-73e3-5cff-e722c560d785}">
+        <p14:section name="KPI de 90 dias" id="{368a014a-2f31-4f6a-7ab2-cf6f19ec8060}">
           <p14:sldIdLst>
             <p14:sldId id="261"/>
           </p14:sldIdLst>
@@ -2188,7 +2188,8 @@
               <a:rPr lang="en-US" dirty="0"/>
               <a:t>Propensão à conversão. Fiz uma análise descritiva: para cada característica do contador, calculei a taxa de conversão de cada categoria. A característica que mais separa quem converte de quem não converte é a que tem maior diferença entre a melhor e a pior categoria. Em ordem: porte, nº de funcionários, nº de clientes da carteira, erp atual e anos de mercado. A propensão de cada contador é a média das taxas de conversão do perfil dele nessas cinco características: sem modelo e sem pesos. O score ordena bem: a faixa Alta, Média e Baixa convertem 91% · 29% · 3%; o top 30% converte 2,3 vezes a média e capta 69% dos convertidos.
 O ponto mais importante está no gráfico: pela base, Médio e Grande convertem quase sempre e o Autônomo quase nunca. Mas no pipeline real o fechamento não segue esse padrão: o Autônomo fecha 67% e o Médio, 46%. E o top 30% do score fecha 60% no pipeline real, contra 65% nas demais faixas. Ou seja, a coluna de conversão mede potencial, não fechamento.
-Por isso trato o impacto como hipótese: +25% de nMRR no cenário base, cerca de R$ 31 mil por mês nas franquias abaixo da meta. Para saber se funciona, a métrica é simples: num piloto de 90 dias, o grupo que prioriza o topo do score fecha mais do que o grupo de controle?</a:t>
+Previsibilidade: o pipeline aberto, ponderado pela chance de fechar de cada estágio, prevê 6,9 Ganhos no próximo trimestre; o run-rate histórico do CRM dá 8,1. Os dois métodos convergem. Os 133 leads parados há mais de 90 dias entram com zero. E um alerta: os Ganhos do CRM somam 0,9% do nMRR oficial, então dá para prever o pipeline, mas não a receita oficial sem uma fonte única.
+Por isso trato o impacto da priorização como hipótese: +25% de nMRR no cenário base, cerca de R$ 31 mil por mês nas franquias abaixo da meta. Para saber se funciona, a métrica é simples: num piloto de 90 dias, o grupo que prioriza o topo do score fecha mais do que o grupo de controle?</a:t>
             </a:r>
             <a:endParaRPr lang="en-US" dirty="0"/>
           </a:p>
@@ -5367,7 +5368,7 @@
                 <a:ea typeface="+mj-lt" pitchFamily="34" charset="-122"/>
                 <a:cs typeface="+mj-lt" pitchFamily="34" charset="-120"/>
               </a:rPr>
-              <a:t>+25% de nMRR</a:t>
+              <a:t>7 a 8 Ganhos</a:t>
             </a:r>
             <a:endParaRPr lang="en-US" sz="1400" dirty="0"/>
           </a:p>
@@ -5381,7 +5382,7 @@
                   <a:schemeClr val="bg1"/>
                 </a:solidFill>
               </a:rPr>
-              <a:t>Cenário base (10% a 46%): ≈ R$ 31 mil/mês nas 9 franquias abaixo da meta, se o piloto confirmar.</a:t>
+              <a:t>previstos no próximo trimestre: pipeline ponderado e run-rate convergem. Priorizar o topo: +25%, se o piloto confirmar.</a:t>
             </a:r>
             <a:endParaRPr lang="en-US" sz="1400" dirty="0"/>
           </a:p>

</xml_diff>

<commit_message>
Receita do plano (+R$ 19,5 mil/mês; playbook no nível do ES até +R$ 26,3 mil) e metas de 90 dias tiradas da base no slide 6
Co-Authored-By: Claude Opus 5.5 <noreply@anthropic.com>
</commit_message>
<xml_diff>
--- a/omie-case-contadores/output/Apresentacao_Omie_Canal_Contadores.pptx
+++ b/omie-case-contadores/output/Apresentacao_Omie_Canal_Contadores.pptx
@@ -112,32 +112,32 @@
   <p:extLst>
     <p:ext uri="{521415D9-36F7-43E2-AB2F-B90AF26B5E84}">
       <p14:sectionLst xmlns:p14="http://schemas.microsoft.com/office/powerpoint/2010/main">
-        <p14:section name="Oportunidade" id="{70f5e4c4-1d61-283c-0832-4b56694c0367}">
+        <p14:section name="Oportunidade" id="{a5cdb9a6-aba3-2f64-83f7-ba3c8a5ba583}">
           <p14:sldIdLst>
             <p14:sldId id="256"/>
           </p14:sldIdLst>
         </p14:section>
-        <p14:section name="Onde está o dinheiro" id="{4de689a4-dc15-9010-02ec-9c30ed352db0}">
+        <p14:section name="Onde está o dinheiro" id="{98cd6bc7-8b06-d87b-cf76-99144635dc42}">
           <p14:sldIdLst>
             <p14:sldId id="257"/>
           </p14:sldIdLst>
         </p14:section>
-        <p14:section name="Drivers de conversão" id="{8e4fd4d7-a7ee-37a8-f858-0f1fbc2c548b}">
+        <p14:section name="Drivers de conversão" id="{6c8c947a-271f-9755-46f8-6e44deebcb31}">
           <p14:sldIdLst>
             <p14:sldId id="258"/>
           </p14:sldIdLst>
         </p14:section>
-        <p14:section name="Capacity e EC adicional" id="{8e8cb24d-c963-327d-31ef-379b01c42264}">
+        <p14:section name="Capacity e EC adicional" id="{76aa7d0b-97af-260c-27bd-0797f36d04f4}">
           <p14:sldIdLst>
             <p14:sldId id="259"/>
           </p14:sldIdLst>
         </p14:section>
-        <p14:section name="Ações imediatas" id="{c23e49cc-3d7f-fed6-426f-7c422a7b9335}">
+        <p14:section name="Ações imediatas" id="{9c27c8cb-6454-384d-aae3-58b1fe0ab0eb}">
           <p14:sldIdLst>
             <p14:sldId id="260"/>
           </p14:sldIdLst>
         </p14:section>
-        <p14:section name="KPI de 90 dias" id="{368a014a-2f31-4f6a-7ab2-cf6f19ec8060}">
+        <p14:section name="KPI de 90 dias" id="{05095b63-17f5-db16-fc16-38df9995aed0}">
           <p14:sldIdLst>
             <p14:sldId id="261"/>
           </p14:sldIdLst>
@@ -2370,7 +2370,7 @@
               <a:t>As três ações para o campo, em ordem de prioridade.
 Primeira: fechar o que já está quente. São 15 contadores com lead ativo em reunião ou proposta, o único sinal real de compra que temos, independente de qualquer perfil. Junto com isso, limpar o pipeline: 56% dos leads abertos estão parados há mais de 90 dias, o dobro do ciclo médio de um ganho. Isso libera tempo de EC e torna a cobertura confiável.
 Segunda: o piloto do tier Alta, a lista priorizada da pergunta C: carteira acima de 24 clientes com lead em andamento, ou de 15 a 24 com lead em reunião ou proposta. São 21 contadores; 8 já estão em negociação, então o piloto ataca os outros 13. Metade dos ECs ataca essa lista, a outra metade é o grupo de controle. Em 90 dias eu sei se o perfil gera receita de verdade.
-Terceira: proposta → fechamento é a etapa de menor conversão, 19%. Cinco pontos percentuais a mais nela valem 26% de nMRR.
+Terceira: proposta → fechamento é a etapa de menor conversão, 19%, e o ES já fecha 23,7%. Se as 9 franquias abaixo da meta chegarem a esse nível, são R$ 26 mil a mais por mês, 135% do gap, sem contratar ninguém. Na BA isso não basta, por isso o EC adicional; no CE o gap é de meta, não de execução.
 Embaixo estão as três decisões de gestão que sustentam isso: meta revista nas franquias pequenas, plano para o RJ e o EC adicional em BA.</a:t>
             </a:r>
             <a:endParaRPr lang="en-US" dirty="0"/>
@@ -2459,8 +2459,8 @@
           <a:p>
             <a:r>
               <a:rPr lang="en-US" dirty="0"/>
-              <a:t>Para fechar: como medir o sucesso em 90 dias. Proponho um único KPI norte, o atingimento de nMRR das 9 franquias que hoje estão abaixo da meta. Elas estão em 86% e a meta é chegar à meta delas, 100%, acompanhado no painel de Power BI que montei sobre a mesma base do case: drivers, contraste com o real, priorização e capacity, tudo lendo direto do SQL Server.
-Os quatro indicadores de suporte medem se as ações estão funcionando: o win rate do piloto contra o grupo de controle, a conversão de proposta para fechamento, o percentual de pipeline parado e a cobertura dos contadores do tier Alta.
+              <a:t>Para fechar: como medir o sucesso em 90 dias. Proponho um único KPI norte, o atingimento de nMRR das 9 franquias que hoje estão abaixo da meta. Elas estão em 86% e a meta é chegar à meta delas, 100%: são R$ 19,5 mil a mais por mês, de R$ 124 mil para R$ 143,5 mil. E o plano sustenta esse número: só o playbook de proposta → fechamento, no nível que o ES já pratica, rende até R$ 26 mil por mês; a priorização pelo score é upside, que só conto depois do piloto. Acompanho tudo no painel de Power BI que montei sobre a mesma base do case.
+Os quatro indicadores de suporte têm meta numérica, e toda meta vem da própria base: win rate do piloto de pelo menos 68,6%, o do Inbound, e acima do controle; proposta → fechamento de 19,3% para 23,7%, o nível do ES; pipeline parado de 56% para zero, porque nenhum Ganho fechou depois de 89 dias; e os 21 contadores do tier Alta em negociação.
 E o pré-requisito, que é o que eu faria primeiro: hoje o nMRR do canal vale R$ 299 mil, R$ 17 mil ou R$ 3 mil por mês, dependendo da tabela que se consulta. Sem uma fonte única, não dá para medir o piloto, calibrar meta nem decidir headcount com segurança. É exatamente o papel da camada semântica de Parcerias.</a:t>
             </a:r>
             <a:endParaRPr lang="en-US" dirty="0"/>
@@ -7042,7 +7042,7 @@
                   <a:schemeClr val="accent1"/>
                 </a:solidFill>
               </a:rPr>
-              <a:t>+5 p.p. nessa etapa = +26% de nMRR</a:t>
+              <a:t>No nível do ES (23,7%): +R$ 26 mil/mês nas 9 franquias</a:t>
             </a:r>
             <a:endParaRPr lang="en-US" sz="1400" dirty="0"/>
           </a:p>
@@ -7573,12 +7573,23 @@
               <a:buNone/>
             </a:pPr>
             <a:r>
+              <a:rPr lang="en-US" sz="1400" b="1" dirty="0">
+                <a:solidFill>
+                  <a:schemeClr val="accent1"/>
+                </a:solidFill>
+              </a:rPr>
+              <a:t>Receita do plano: +R$ 19,5 mil/mês. </a:t>
+            </a:r>
+            <a:pPr indent="0" marL="0">
+              <a:buNone/>
+            </a:pPr>
+            <a:r>
               <a:rPr lang="en-US" sz="1400" dirty="0">
                 <a:solidFill>
                   <a:schemeClr val="bg1"/>
                 </a:solidFill>
               </a:rPr>
-              <a:t>Acompanhamento por franquia no Painel Omie (Power BI), a mesma base do case.</a:t>
+              <a:t>Só o playbook de fechamento rende até +R$ 26 mil/mês.</a:t>
             </a:r>
             <a:endParaRPr lang="en-US" sz="1200" dirty="0"/>
           </a:p>
@@ -7758,10 +7769,10 @@
             <a:tbl>
               <a:tblPr/>
               <a:tblGrid>
-                <a:gridCol w="2697480"/>
-                <a:gridCol w="1234440"/>
-                <a:gridCol w="1508760"/>
-                <a:gridCol w="1627632"/>
+                <a:gridCol w="2331720"/>
+                <a:gridCol w="1051560"/>
+                <a:gridCol w="1600200"/>
+                <a:gridCol w="2084832"/>
               </a:tblGrid>
               <a:tr h="475488">
                 <a:tc>
@@ -7773,7 +7784,7 @@
                         <a:buNone/>
                       </a:pPr>
                       <a:r>
-                        <a:rPr lang="en-US" sz="1300" b="1" dirty="0">
+                        <a:rPr lang="en-US" sz="1200" b="1" dirty="0">
                           <a:solidFill>
                             <a:srgbClr val="FFFFFF"/>
                           </a:solidFill>
@@ -7783,7 +7794,7 @@
                         </a:rPr>
                         <a:t>KPI de suporte</a:t>
                       </a:r>
-                      <a:endParaRPr lang="en-US" sz="1300" dirty="0">
+                      <a:endParaRPr lang="en-US" sz="1200" dirty="0">
                         <a:latin typeface="Calibri" charset="0"/>
                         <a:ea typeface="Calibri" charset="0"/>
                         <a:cs typeface="Calibri" charset="0"/>
@@ -7841,7 +7852,7 @@
                         <a:buNone/>
                       </a:pPr>
                       <a:r>
-                        <a:rPr lang="en-US" sz="1300" b="1" dirty="0">
+                        <a:rPr lang="en-US" sz="1200" b="1" dirty="0">
                           <a:solidFill>
                             <a:srgbClr val="FFFFFF"/>
                           </a:solidFill>
@@ -7851,7 +7862,7 @@
                         </a:rPr>
                         <a:t>Hoje</a:t>
                       </a:r>
-                      <a:endParaRPr lang="en-US" sz="1300" dirty="0">
+                      <a:endParaRPr lang="en-US" sz="1200" dirty="0">
                         <a:latin typeface="Calibri" charset="0"/>
                         <a:ea typeface="Calibri" charset="0"/>
                         <a:cs typeface="Calibri" charset="0"/>
@@ -7909,7 +7920,7 @@
                         <a:buNone/>
                       </a:pPr>
                       <a:r>
-                        <a:rPr lang="en-US" sz="1300" b="1" dirty="0">
+                        <a:rPr lang="en-US" sz="1200" b="1" dirty="0">
                           <a:solidFill>
                             <a:srgbClr val="FFFFFF"/>
                           </a:solidFill>
@@ -7917,9 +7928,9 @@
                           <a:ea typeface="Calibri" pitchFamily="34" charset="-122"/>
                           <a:cs typeface="Calibri" pitchFamily="34" charset="-120"/>
                         </a:rPr>
-                        <a:t>Sinal de sucesso</a:t>
+                        <a:t>Meta 90 dias</a:t>
                       </a:r>
-                      <a:endParaRPr lang="en-US" sz="1300" dirty="0">
+                      <a:endParaRPr lang="en-US" sz="1200" dirty="0">
                         <a:latin typeface="Calibri" charset="0"/>
                         <a:ea typeface="Calibri" charset="0"/>
                         <a:cs typeface="Calibri" charset="0"/>
@@ -7977,7 +7988,7 @@
                         <a:buNone/>
                       </a:pPr>
                       <a:r>
-                        <a:rPr lang="en-US" sz="1300" b="1" dirty="0">
+                        <a:rPr lang="en-US" sz="1200" b="1" dirty="0">
                           <a:solidFill>
                             <a:srgbClr val="FFFFFF"/>
                           </a:solidFill>
@@ -7985,9 +7996,9 @@
                           <a:ea typeface="Calibri" pitchFamily="34" charset="-122"/>
                           <a:cs typeface="Calibri" pitchFamily="34" charset="-120"/>
                         </a:rPr>
-                        <a:t>Por quê</a:t>
+                        <a:t>De onde vem a meta</a:t>
                       </a:r>
-                      <a:endParaRPr lang="en-US" sz="1300" dirty="0">
+                      <a:endParaRPr lang="en-US" sz="1200" dirty="0">
                         <a:latin typeface="Calibri" charset="0"/>
                         <a:ea typeface="Calibri" charset="0"/>
                         <a:cs typeface="Calibri" charset="0"/>
@@ -8047,7 +8058,7 @@
                         <a:buNone/>
                       </a:pPr>
                       <a:r>
-                        <a:rPr lang="en-US" sz="1300" dirty="0">
+                        <a:rPr lang="en-US" sz="1200" dirty="0">
                           <a:solidFill>
                             <a:srgbClr val="001E27"/>
                           </a:solidFill>
@@ -8055,9 +8066,9 @@
                           <a:ea typeface="Calibri" pitchFamily="34" charset="-122"/>
                           <a:cs typeface="Calibri" pitchFamily="34" charset="-120"/>
                         </a:rPr>
-                        <a:t>Win rate do tier Alta (piloto vs controle)</a:t>
+                        <a:t>Win rate do tier Alta (piloto)</a:t>
                       </a:r>
-                      <a:endParaRPr lang="en-US" sz="1300" dirty="0">
+                      <a:endParaRPr lang="en-US" sz="1200" dirty="0">
                         <a:latin typeface="Calibri" charset="0"/>
                         <a:ea typeface="Calibri" charset="0"/>
                         <a:cs typeface="Calibri" charset="0"/>
@@ -8112,7 +8123,7 @@
                         <a:buNone/>
                       </a:pPr>
                       <a:r>
-                        <a:rPr lang="en-US" sz="1300" dirty="0">
+                        <a:rPr lang="en-US" sz="1200" dirty="0">
                           <a:solidFill>
                             <a:srgbClr val="001E27"/>
                           </a:solidFill>
@@ -8122,7 +8133,7 @@
                         </a:rPr>
                         <a:t>64% (rede)</a:t>
                       </a:r>
-                      <a:endParaRPr lang="en-US" sz="1300" dirty="0">
+                      <a:endParaRPr lang="en-US" sz="1200" dirty="0">
                         <a:latin typeface="Calibri" charset="0"/>
                         <a:ea typeface="Calibri" charset="0"/>
                         <a:cs typeface="Calibri" charset="0"/>
@@ -8177,7 +8188,7 @@
                         <a:buNone/>
                       </a:pPr>
                       <a:r>
-                        <a:rPr lang="en-US" sz="1300" dirty="0">
+                        <a:rPr lang="en-US" sz="1200" dirty="0">
                           <a:solidFill>
                             <a:srgbClr val="001E27"/>
                           </a:solidFill>
@@ -8185,9 +8196,9 @@
                           <a:ea typeface="Calibri" pitchFamily="34" charset="-122"/>
                           <a:cs typeface="Calibri" pitchFamily="34" charset="-120"/>
                         </a:rPr>
-                        <a:t>Piloto acima do controle</a:t>
+                        <a:t>≥ 68,6% e acima do controle</a:t>
                       </a:r>
-                      <a:endParaRPr lang="en-US" sz="1300" dirty="0">
+                      <a:endParaRPr lang="en-US" sz="1200" dirty="0">
                         <a:latin typeface="Calibri" charset="0"/>
                         <a:ea typeface="Calibri" charset="0"/>
                         <a:cs typeface="Calibri" charset="0"/>
@@ -8242,7 +8253,7 @@
                         <a:buNone/>
                       </a:pPr>
                       <a:r>
-                        <a:rPr lang="en-US" sz="1300" dirty="0">
+                        <a:rPr lang="en-US" sz="1200" dirty="0">
                           <a:solidFill>
                             <a:srgbClr val="001E27"/>
                           </a:solidFill>
@@ -8250,9 +8261,9 @@
                           <a:ea typeface="Calibri" pitchFamily="34" charset="-122"/>
                           <a:cs typeface="Calibri" pitchFamily="34" charset="-120"/>
                         </a:rPr>
-                        <a:t>Valida o perfil</a:t>
+                        <a:t>Inbound: melhor canal com 30+ leads encerrados</a:t>
                       </a:r>
-                      <a:endParaRPr lang="en-US" sz="1300" dirty="0">
+                      <a:endParaRPr lang="en-US" sz="1200" dirty="0">
                         <a:latin typeface="Calibri" charset="0"/>
                         <a:ea typeface="Calibri" charset="0"/>
                         <a:cs typeface="Calibri" charset="0"/>
@@ -8309,7 +8320,7 @@
                         <a:buNone/>
                       </a:pPr>
                       <a:r>
-                        <a:rPr lang="en-US" sz="1300" dirty="0">
+                        <a:rPr lang="en-US" sz="1200" dirty="0">
                           <a:solidFill>
                             <a:srgbClr val="001E27"/>
                           </a:solidFill>
@@ -8319,7 +8330,7 @@
                         </a:rPr>
                         <a:t>Conversão proposta → fechamento</a:t>
                       </a:r>
-                      <a:endParaRPr lang="en-US" sz="1300" dirty="0">
+                      <a:endParaRPr lang="en-US" sz="1200" dirty="0">
                         <a:latin typeface="Calibri" charset="0"/>
                         <a:ea typeface="Calibri" charset="0"/>
                         <a:cs typeface="Calibri" charset="0"/>
@@ -8374,7 +8385,7 @@
                         <a:buNone/>
                       </a:pPr>
                       <a:r>
-                        <a:rPr lang="en-US" sz="1300" dirty="0">
+                        <a:rPr lang="en-US" sz="1200" dirty="0">
                           <a:solidFill>
                             <a:srgbClr val="001E27"/>
                           </a:solidFill>
@@ -8382,9 +8393,9 @@
                           <a:ea typeface="Calibri" pitchFamily="34" charset="-122"/>
                           <a:cs typeface="Calibri" pitchFamily="34" charset="-120"/>
                         </a:rPr>
-                        <a:t>19%</a:t>
+                        <a:t>19,3%</a:t>
                       </a:r>
-                      <a:endParaRPr lang="en-US" sz="1300" dirty="0">
+                      <a:endParaRPr lang="en-US" sz="1200" dirty="0">
                         <a:latin typeface="Calibri" charset="0"/>
                         <a:ea typeface="Calibri" charset="0"/>
                         <a:cs typeface="Calibri" charset="0"/>
@@ -8439,7 +8450,7 @@
                         <a:buNone/>
                       </a:pPr>
                       <a:r>
-                        <a:rPr lang="en-US" sz="1300" dirty="0">
+                        <a:rPr lang="en-US" sz="1200" dirty="0">
                           <a:solidFill>
                             <a:srgbClr val="001E27"/>
                           </a:solidFill>
@@ -8447,9 +8458,9 @@
                           <a:ea typeface="Calibri" pitchFamily="34" charset="-122"/>
                           <a:cs typeface="Calibri" pitchFamily="34" charset="-120"/>
                         </a:rPr>
-                        <a:t>Subir</a:t>
+                        <a:t>23,7%</a:t>
                       </a:r>
-                      <a:endParaRPr lang="en-US" sz="1300" dirty="0">
+                      <a:endParaRPr lang="en-US" sz="1200" dirty="0">
                         <a:latin typeface="Calibri" charset="0"/>
                         <a:ea typeface="Calibri" charset="0"/>
                         <a:cs typeface="Calibri" charset="0"/>
@@ -8504,7 +8515,7 @@
                         <a:buNone/>
                       </a:pPr>
                       <a:r>
-                        <a:rPr lang="en-US" sz="1300" dirty="0">
+                        <a:rPr lang="en-US" sz="1200" dirty="0">
                           <a:solidFill>
                             <a:srgbClr val="001E27"/>
                           </a:solidFill>
@@ -8512,9 +8523,9 @@
                           <a:ea typeface="Calibri" pitchFamily="34" charset="-122"/>
                           <a:cs typeface="Calibri" pitchFamily="34" charset="-120"/>
                         </a:rPr>
-                        <a:t>Maior alavanca do funil</a:t>
+                        <a:t>ES: melhor franquia da rede</a:t>
                       </a:r>
-                      <a:endParaRPr lang="en-US" sz="1300" dirty="0">
+                      <a:endParaRPr lang="en-US" sz="1200" dirty="0">
                         <a:latin typeface="Calibri" charset="0"/>
                         <a:ea typeface="Calibri" charset="0"/>
                         <a:cs typeface="Calibri" charset="0"/>
@@ -8571,7 +8582,7 @@
                         <a:buNone/>
                       </a:pPr>
                       <a:r>
-                        <a:rPr lang="en-US" sz="1300" dirty="0">
+                        <a:rPr lang="en-US" sz="1200" dirty="0">
                           <a:solidFill>
                             <a:srgbClr val="001E27"/>
                           </a:solidFill>
@@ -8581,7 +8592,7 @@
                         </a:rPr>
                         <a:t>Leads abertos parados há +90 dias</a:t>
                       </a:r>
-                      <a:endParaRPr lang="en-US" sz="1300" dirty="0">
+                      <a:endParaRPr lang="en-US" sz="1200" dirty="0">
                         <a:latin typeface="Calibri" charset="0"/>
                         <a:ea typeface="Calibri" charset="0"/>
                         <a:cs typeface="Calibri" charset="0"/>
@@ -8636,7 +8647,7 @@
                         <a:buNone/>
                       </a:pPr>
                       <a:r>
-                        <a:rPr lang="en-US" sz="1300" dirty="0">
+                        <a:rPr lang="en-US" sz="1200" dirty="0">
                           <a:solidFill>
                             <a:srgbClr val="001E27"/>
                           </a:solidFill>
@@ -8646,7 +8657,7 @@
                         </a:rPr>
                         <a:t>56%</a:t>
                       </a:r>
-                      <a:endParaRPr lang="en-US" sz="1300" dirty="0">
+                      <a:endParaRPr lang="en-US" sz="1200" dirty="0">
                         <a:latin typeface="Calibri" charset="0"/>
                         <a:ea typeface="Calibri" charset="0"/>
                         <a:cs typeface="Calibri" charset="0"/>
@@ -8701,7 +8712,7 @@
                         <a:buNone/>
                       </a:pPr>
                       <a:r>
-                        <a:rPr lang="en-US" sz="1300" dirty="0">
+                        <a:rPr lang="en-US" sz="1200" dirty="0">
                           <a:solidFill>
                             <a:srgbClr val="001E27"/>
                           </a:solidFill>
@@ -8709,9 +8720,9 @@
                           <a:ea typeface="Calibri" pitchFamily="34" charset="-122"/>
                           <a:cs typeface="Calibri" pitchFamily="34" charset="-120"/>
                         </a:rPr>
-                        <a:t>Cair</a:t>
+                        <a:t>0%</a:t>
                       </a:r>
-                      <a:endParaRPr lang="en-US" sz="1300" dirty="0">
+                      <a:endParaRPr lang="en-US" sz="1200" dirty="0">
                         <a:latin typeface="Calibri" charset="0"/>
                         <a:ea typeface="Calibri" charset="0"/>
                         <a:cs typeface="Calibri" charset="0"/>
@@ -8766,7 +8777,7 @@
                         <a:buNone/>
                       </a:pPr>
                       <a:r>
-                        <a:rPr lang="en-US" sz="1300" dirty="0">
+                        <a:rPr lang="en-US" sz="1200" dirty="0">
                           <a:solidFill>
                             <a:srgbClr val="001E27"/>
                           </a:solidFill>
@@ -8774,9 +8785,9 @@
                           <a:ea typeface="Calibri" pitchFamily="34" charset="-122"/>
                           <a:cs typeface="Calibri" pitchFamily="34" charset="-120"/>
                         </a:rPr>
-                        <a:t>Pipeline confiável</a:t>
+                        <a:t>Nenhum Ganho fechou depois de 89 dias</a:t>
                       </a:r>
-                      <a:endParaRPr lang="en-US" sz="1300" dirty="0">
+                      <a:endParaRPr lang="en-US" sz="1200" dirty="0">
                         <a:latin typeface="Calibri" charset="0"/>
                         <a:ea typeface="Calibri" charset="0"/>
                         <a:cs typeface="Calibri" charset="0"/>
@@ -8833,7 +8844,7 @@
                         <a:buNone/>
                       </a:pPr>
                       <a:r>
-                        <a:rPr lang="en-US" sz="1300" dirty="0">
+                        <a:rPr lang="en-US" sz="1200" dirty="0">
                           <a:solidFill>
                             <a:srgbClr val="001E27"/>
                           </a:solidFill>
@@ -8843,7 +8854,7 @@
                         </a:rPr>
                         <a:t>Tier Alta com lead em Reunião/Proposta</a:t>
                       </a:r>
-                      <a:endParaRPr lang="en-US" sz="1300" dirty="0">
+                      <a:endParaRPr lang="en-US" sz="1200" dirty="0">
                         <a:latin typeface="Calibri" charset="0"/>
                         <a:ea typeface="Calibri" charset="0"/>
                         <a:cs typeface="Calibri" charset="0"/>
@@ -8898,7 +8909,7 @@
                         <a:buNone/>
                       </a:pPr>
                       <a:r>
-                        <a:rPr lang="en-US" sz="1300" dirty="0">
+                        <a:rPr lang="en-US" sz="1200" dirty="0">
                           <a:solidFill>
                             <a:srgbClr val="001E27"/>
                           </a:solidFill>
@@ -8908,7 +8919,7 @@
                         </a:rPr>
                         <a:t>8 de 21</a:t>
                       </a:r>
-                      <a:endParaRPr lang="en-US" sz="1300" dirty="0">
+                      <a:endParaRPr lang="en-US" sz="1200" dirty="0">
                         <a:latin typeface="Calibri" charset="0"/>
                         <a:ea typeface="Calibri" charset="0"/>
                         <a:cs typeface="Calibri" charset="0"/>
@@ -8963,7 +8974,7 @@
                         <a:buNone/>
                       </a:pPr>
                       <a:r>
-                        <a:rPr lang="en-US" sz="1300" dirty="0">
+                        <a:rPr lang="en-US" sz="1200" dirty="0">
                           <a:solidFill>
                             <a:srgbClr val="001E27"/>
                           </a:solidFill>
@@ -8971,9 +8982,9 @@
                           <a:ea typeface="Calibri" pitchFamily="34" charset="-122"/>
                           <a:cs typeface="Calibri" pitchFamily="34" charset="-120"/>
                         </a:rPr>
-                        <a:t>Todos</a:t>
+                        <a:t>21 de 21</a:t>
                       </a:r>
-                      <a:endParaRPr lang="en-US" sz="1300" dirty="0">
+                      <a:endParaRPr lang="en-US" sz="1200" dirty="0">
                         <a:latin typeface="Calibri" charset="0"/>
                         <a:ea typeface="Calibri" charset="0"/>
                         <a:cs typeface="Calibri" charset="0"/>
@@ -9028,7 +9039,7 @@
                         <a:buNone/>
                       </a:pPr>
                       <a:r>
-                        <a:rPr lang="en-US" sz="1300" dirty="0">
+                        <a:rPr lang="en-US" sz="1200" dirty="0">
                           <a:solidFill>
                             <a:srgbClr val="001E27"/>
                           </a:solidFill>
@@ -9036,9 +9047,9 @@
                           <a:ea typeface="Calibri" pitchFamily="34" charset="-122"/>
                           <a:cs typeface="Calibri" pitchFamily="34" charset="-120"/>
                         </a:rPr>
-                        <a:t>Cobertura do tier Alta</a:t>
+                        <a:t>Cobertura total do tier Alta</a:t>
                       </a:r>
-                      <a:endParaRPr lang="en-US" sz="1300" dirty="0">
+                      <a:endParaRPr lang="en-US" sz="1200" dirty="0">
                         <a:latin typeface="Calibri" charset="0"/>
                         <a:ea typeface="Calibri" charset="0"/>
                         <a:cs typeface="Calibri" charset="0"/>
@@ -9209,7 +9220,7 @@
                   <a:srgbClr val="4E6B74"/>
                 </a:solidFill>
               </a:rPr>
-              <a:t>Hoje: franquias, leads_pipeline e Desafio 3 · Painel Omie (Power BI) · sinais de sucesso a validar com a liderança</a:t>
+              <a:t>Hoje: franquias, leads_pipeline e Desafio 3 · metas: referências da própria base · receita: Desafio3_Capacity.xlsx (Simulador_Funil)</a:t>
             </a:r>
             <a:endParaRPr lang="en-US" sz="1000" dirty="0"/>
           </a:p>

</xml_diff>

<commit_message>
Avaliação do D2 em 3 perguntas (target, real, piloto) no Excel e no painel
Co-Authored-By: Claude Opus 5.5 <noreply@anthropic.com>
</commit_message>
<xml_diff>
--- a/omie-case-contadores/output/Apresentacao_Omie_Canal_Contadores.pptx
+++ b/omie-case-contadores/output/Apresentacao_Omie_Canal_Contadores.pptx
@@ -112,32 +112,32 @@
   <p:extLst>
     <p:ext uri="{521415D9-36F7-43E2-AB2F-B90AF26B5E84}">
       <p14:sectionLst xmlns:p14="http://schemas.microsoft.com/office/powerpoint/2010/main">
-        <p14:section name="Oportunidade" id="{a5cdb9a6-aba3-2f64-83f7-ba3c8a5ba583}">
+        <p14:section name="Oportunidade" id="{bd59c954-b629-05a3-5073-567027ee4c26}">
           <p14:sldIdLst>
             <p14:sldId id="256"/>
           </p14:sldIdLst>
         </p14:section>
-        <p14:section name="Onde está o dinheiro" id="{98cd6bc7-8b06-d87b-cf76-99144635dc42}">
+        <p14:section name="Onde está o dinheiro" id="{6e9ac9c1-db0e-856b-d1f9-5ed9703ed41a}">
           <p14:sldIdLst>
             <p14:sldId id="257"/>
           </p14:sldIdLst>
         </p14:section>
-        <p14:section name="Drivers de conversão" id="{6c8c947a-271f-9755-46f8-6e44deebcb31}">
+        <p14:section name="Drivers de conversão" id="{1ab90ab1-a851-6369-77f6-5d9928a9114f}">
           <p14:sldIdLst>
             <p14:sldId id="258"/>
           </p14:sldIdLst>
         </p14:section>
-        <p14:section name="Capacity e EC adicional" id="{76aa7d0b-97af-260c-27bd-0797f36d04f4}">
+        <p14:section name="Capacity e EC adicional" id="{8b7c573a-05be-6f77-f1f2-c710aacceece}">
           <p14:sldIdLst>
             <p14:sldId id="259"/>
           </p14:sldIdLst>
         </p14:section>
-        <p14:section name="Ações imediatas" id="{9c27c8cb-6454-384d-aae3-58b1fe0ab0eb}">
+        <p14:section name="Ações imediatas" id="{a454b0c5-b862-3551-5ad3-23e595bee4de}">
           <p14:sldIdLst>
             <p14:sldId id="260"/>
           </p14:sldIdLst>
         </p14:section>
-        <p14:section name="KPI de 90 dias" id="{05095b63-17f5-db16-fc16-38df9995aed0}">
+        <p14:section name="KPI de 90 dias" id="{e0b5f37a-6a0f-7462-d855-b51468e3730f}">
           <p14:sldIdLst>
             <p14:sldId id="261"/>
           </p14:sldIdLst>

</xml_diff>